<commit_message>
presentation: fit slide chart sizing to avoid takeaway/bullet overlap
</commit_message>
<xml_diff>
--- a/presentation/nexamart_m2_presentation.pptx
+++ b/presentation/nexamart_m2_presentation.pptx
@@ -3389,8 +3389,8 @@
         </p:blipFill>
         <p:spPr>
           <a:xfrm>
-            <a:off x="411480" y="1417320"/>
-            <a:ext cx="6766560" cy="4815644"/>
+            <a:off x="365760" y="1371600"/>
+            <a:ext cx="6231484" cy="4434840"/>
           </a:xfrm>
           <a:prstGeom prst="rect">
             <a:avLst/>
@@ -3406,7 +3406,7 @@
         <p:spPr>
           <a:xfrm>
             <a:off x="7406640" y="1554480"/>
-            <a:ext cx="4389120" cy="4206240"/>
+            <a:ext cx="4434840" cy="4206240"/>
           </a:xfrm>
           <a:prstGeom prst="rect">
             <a:avLst/>
@@ -3692,8 +3692,8 @@
         </p:blipFill>
         <p:spPr>
           <a:xfrm>
-            <a:off x="411480" y="1417320"/>
-            <a:ext cx="6766560" cy="3721329"/>
+            <a:off x="365760" y="1371600"/>
+            <a:ext cx="6858000" cy="3771616"/>
           </a:xfrm>
           <a:prstGeom prst="rect">
             <a:avLst/>
@@ -3709,7 +3709,7 @@
         <p:spPr>
           <a:xfrm>
             <a:off x="7406640" y="1554480"/>
-            <a:ext cx="4389120" cy="4206240"/>
+            <a:ext cx="4434840" cy="4206240"/>
           </a:xfrm>
           <a:prstGeom prst="rect">
             <a:avLst/>
@@ -3995,8 +3995,8 @@
         </p:blipFill>
         <p:spPr>
           <a:xfrm>
-            <a:off x="822960" y="1508760"/>
-            <a:ext cx="10515600" cy="2805602"/>
+            <a:off x="692005" y="1508760"/>
+            <a:ext cx="10795796" cy="2880360"/>
           </a:xfrm>
           <a:prstGeom prst="rect">
             <a:avLst/>
@@ -4282,8 +4282,8 @@
         </p:blipFill>
         <p:spPr>
           <a:xfrm>
-            <a:off x="411480" y="1417320"/>
-            <a:ext cx="6766560" cy="5222915"/>
+            <a:off x="365760" y="1371600"/>
+            <a:ext cx="5745567" cy="4434840"/>
           </a:xfrm>
           <a:prstGeom prst="rect">
             <a:avLst/>
@@ -4299,7 +4299,7 @@
         <p:spPr>
           <a:xfrm>
             <a:off x="7406640" y="1554480"/>
-            <a:ext cx="4389120" cy="4206240"/>
+            <a:ext cx="4434840" cy="4206240"/>
           </a:xfrm>
           <a:prstGeom prst="rect">
             <a:avLst/>
@@ -4585,8 +4585,8 @@
         </p:blipFill>
         <p:spPr>
           <a:xfrm>
-            <a:off x="411480" y="1417320"/>
-            <a:ext cx="6766560" cy="5182739"/>
+            <a:off x="365760" y="1371600"/>
+            <a:ext cx="5790106" cy="4434840"/>
           </a:xfrm>
           <a:prstGeom prst="rect">
             <a:avLst/>
@@ -4602,7 +4602,7 @@
         <p:spPr>
           <a:xfrm>
             <a:off x="7406640" y="1554480"/>
-            <a:ext cx="4389120" cy="4206240"/>
+            <a:ext cx="4434840" cy="4206240"/>
           </a:xfrm>
           <a:prstGeom prst="rect">
             <a:avLst/>
@@ -4888,8 +4888,8 @@
         </p:blipFill>
         <p:spPr>
           <a:xfrm>
-            <a:off x="411480" y="1417320"/>
-            <a:ext cx="6766560" cy="5048182"/>
+            <a:off x="365760" y="1371600"/>
+            <a:ext cx="5944439" cy="4434840"/>
           </a:xfrm>
           <a:prstGeom prst="rect">
             <a:avLst/>
@@ -4905,7 +4905,7 @@
         <p:spPr>
           <a:xfrm>
             <a:off x="7406640" y="1554480"/>
-            <a:ext cx="4389120" cy="4206240"/>
+            <a:ext cx="4434840" cy="4206240"/>
           </a:xfrm>
           <a:prstGeom prst="rect">
             <a:avLst/>
@@ -5191,8 +5191,8 @@
         </p:blipFill>
         <p:spPr>
           <a:xfrm>
-            <a:off x="411480" y="1417320"/>
-            <a:ext cx="6766560" cy="4707467"/>
+            <a:off x="365760" y="1371600"/>
+            <a:ext cx="6374683" cy="4434840"/>
           </a:xfrm>
           <a:prstGeom prst="rect">
             <a:avLst/>
@@ -5208,7 +5208,7 @@
         <p:spPr>
           <a:xfrm>
             <a:off x="7406640" y="1554480"/>
-            <a:ext cx="4389120" cy="4206240"/>
+            <a:ext cx="4434840" cy="4206240"/>
           </a:xfrm>
           <a:prstGeom prst="rect">
             <a:avLst/>
@@ -5494,8 +5494,8 @@
         </p:blipFill>
         <p:spPr>
           <a:xfrm>
-            <a:off x="411480" y="1417320"/>
-            <a:ext cx="6766560" cy="5225288"/>
+            <a:off x="365760" y="1371600"/>
+            <a:ext cx="5742958" cy="4434840"/>
           </a:xfrm>
           <a:prstGeom prst="rect">
             <a:avLst/>
@@ -5511,7 +5511,7 @@
         <p:spPr>
           <a:xfrm>
             <a:off x="7406640" y="1554480"/>
-            <a:ext cx="4389120" cy="4206240"/>
+            <a:ext cx="4434840" cy="4206240"/>
           </a:xfrm>
           <a:prstGeom prst="rect">
             <a:avLst/>
@@ -5797,8 +5797,8 @@
         </p:blipFill>
         <p:spPr>
           <a:xfrm>
-            <a:off x="411480" y="1417320"/>
-            <a:ext cx="6766560" cy="5225288"/>
+            <a:off x="365760" y="1371600"/>
+            <a:ext cx="5742958" cy="4434840"/>
           </a:xfrm>
           <a:prstGeom prst="rect">
             <a:avLst/>
@@ -5814,7 +5814,7 @@
         <p:spPr>
           <a:xfrm>
             <a:off x="7406640" y="1554480"/>
-            <a:ext cx="4389120" cy="4206240"/>
+            <a:ext cx="4434840" cy="4206240"/>
           </a:xfrm>
           <a:prstGeom prst="rect">
             <a:avLst/>

</xml_diff>

<commit_message>
presentation: tag each appendix screenshot with its evidence code (E1-E6)
- Add a navy E-code badge above every evidence/dashboard screenshot in the
  appendix (E1 build, E2 detection, E3 resolution, E4 validation,
  E5 reconciled KPIs, E6 dashboard) so the (E#) citations on the core slides
  resolve visually and can be referenced while presenting
- Replace the appendix-divider order line with an explicit evidence-map legend
</commit_message>
<xml_diff>
--- a/presentation/nexamart_m2_presentation.pptx
+++ b/presentation/nexamart_m2_presentation.pptx
@@ -16374,7 +16374,7 @@
                 </a:solidFill>
                 <a:latin typeface="Aptos"/>
               </a:rPr>
-              <a:t>Order: schemas &amp; layers → anomaly detection/resolution → validation → reconciled KPIs → dashboard.</a:t>
+              <a:t>Evidence map:  E1 schemas &amp; layers · E2 detection · E3 resolution · E4 validation · E5 reconciled KPIs · E6 dashboard</a:t>
             </a:r>
           </a:p>
         </p:txBody>
@@ -16647,6 +16647,112 @@
           </a:prstGeom>
         </p:spPr>
       </p:pic>
+      <p:sp>
+        <p:nvSpPr>
+          <p:cNvPr id="11" name="Rounded Rectangle 10"/>
+          <p:cNvSpPr/>
+          <p:nvPr/>
+        </p:nvSpPr>
+        <p:spPr>
+          <a:xfrm>
+            <a:off x="411480" y="1243584"/>
+            <a:ext cx="548640" cy="274320"/>
+          </a:xfrm>
+          <a:prstGeom prst="roundRect">
+            <a:avLst/>
+          </a:prstGeom>
+          <a:solidFill>
+            <a:srgbClr val="10243E"/>
+          </a:solidFill>
+          <a:ln>
+            <a:noFill/>
+          </a:ln>
+          <a:effectLst/>
+        </p:spPr>
+        <p:style>
+          <a:lnRef idx="1">
+            <a:schemeClr val="accent1"/>
+          </a:lnRef>
+          <a:fillRef idx="3">
+            <a:schemeClr val="accent1"/>
+          </a:fillRef>
+          <a:effectRef idx="2">
+            <a:schemeClr val="accent1"/>
+          </a:effectRef>
+          <a:fontRef idx="minor">
+            <a:schemeClr val="lt1"/>
+          </a:fontRef>
+        </p:style>
+        <p:txBody>
+          <a:bodyPr rtlCol="0" anchor="ctr" wrap="none" lIns="0" rIns="0" tIns="0" bIns="0"/>
+          <a:lstStyle/>
+          <a:p>
+            <a:pPr algn="ctr"/>
+            <a:r>
+              <a:rPr sz="1300" b="1">
+                <a:solidFill>
+                  <a:srgbClr val="FFFFFF"/>
+                </a:solidFill>
+                <a:latin typeface="Aptos"/>
+              </a:rPr>
+              <a:t>E1</a:t>
+            </a:r>
+          </a:p>
+        </p:txBody>
+      </p:sp>
+      <p:sp>
+        <p:nvSpPr>
+          <p:cNvPr id="12" name="Rounded Rectangle 11"/>
+          <p:cNvSpPr/>
+          <p:nvPr/>
+        </p:nvSpPr>
+        <p:spPr>
+          <a:xfrm>
+            <a:off x="6199632" y="1243584"/>
+            <a:ext cx="548640" cy="274320"/>
+          </a:xfrm>
+          <a:prstGeom prst="roundRect">
+            <a:avLst/>
+          </a:prstGeom>
+          <a:solidFill>
+            <a:srgbClr val="10243E"/>
+          </a:solidFill>
+          <a:ln>
+            <a:noFill/>
+          </a:ln>
+          <a:effectLst/>
+        </p:spPr>
+        <p:style>
+          <a:lnRef idx="1">
+            <a:schemeClr val="accent1"/>
+          </a:lnRef>
+          <a:fillRef idx="3">
+            <a:schemeClr val="accent1"/>
+          </a:fillRef>
+          <a:effectRef idx="2">
+            <a:schemeClr val="accent1"/>
+          </a:effectRef>
+          <a:fontRef idx="minor">
+            <a:schemeClr val="lt1"/>
+          </a:fontRef>
+        </p:style>
+        <p:txBody>
+          <a:bodyPr rtlCol="0" anchor="ctr" wrap="none" lIns="0" rIns="0" tIns="0" bIns="0"/>
+          <a:lstStyle/>
+          <a:p>
+            <a:pPr algn="ctr"/>
+            <a:r>
+              <a:rPr sz="1300" b="1">
+                <a:solidFill>
+                  <a:srgbClr val="FFFFFF"/>
+                </a:solidFill>
+                <a:latin typeface="Aptos"/>
+              </a:rPr>
+              <a:t>E1</a:t>
+            </a:r>
+          </a:p>
+        </p:txBody>
+      </p:sp>
     </p:spTree>
   </p:cSld>
   <p:clrMapOvr>
@@ -16915,6 +17021,112 @@
           </a:prstGeom>
         </p:spPr>
       </p:pic>
+      <p:sp>
+        <p:nvSpPr>
+          <p:cNvPr id="11" name="Rounded Rectangle 10"/>
+          <p:cNvSpPr/>
+          <p:nvPr/>
+        </p:nvSpPr>
+        <p:spPr>
+          <a:xfrm>
+            <a:off x="411480" y="1243584"/>
+            <a:ext cx="548640" cy="274320"/>
+          </a:xfrm>
+          <a:prstGeom prst="roundRect">
+            <a:avLst/>
+          </a:prstGeom>
+          <a:solidFill>
+            <a:srgbClr val="10243E"/>
+          </a:solidFill>
+          <a:ln>
+            <a:noFill/>
+          </a:ln>
+          <a:effectLst/>
+        </p:spPr>
+        <p:style>
+          <a:lnRef idx="1">
+            <a:schemeClr val="accent1"/>
+          </a:lnRef>
+          <a:fillRef idx="3">
+            <a:schemeClr val="accent1"/>
+          </a:fillRef>
+          <a:effectRef idx="2">
+            <a:schemeClr val="accent1"/>
+          </a:effectRef>
+          <a:fontRef idx="minor">
+            <a:schemeClr val="lt1"/>
+          </a:fontRef>
+        </p:style>
+        <p:txBody>
+          <a:bodyPr rtlCol="0" anchor="ctr" wrap="none" lIns="0" rIns="0" tIns="0" bIns="0"/>
+          <a:lstStyle/>
+          <a:p>
+            <a:pPr algn="ctr"/>
+            <a:r>
+              <a:rPr sz="1300" b="1">
+                <a:solidFill>
+                  <a:srgbClr val="FFFFFF"/>
+                </a:solidFill>
+                <a:latin typeface="Aptos"/>
+              </a:rPr>
+              <a:t>E5</a:t>
+            </a:r>
+          </a:p>
+        </p:txBody>
+      </p:sp>
+      <p:sp>
+        <p:nvSpPr>
+          <p:cNvPr id="12" name="Rounded Rectangle 11"/>
+          <p:cNvSpPr/>
+          <p:nvPr/>
+        </p:nvSpPr>
+        <p:spPr>
+          <a:xfrm>
+            <a:off x="6199632" y="1243584"/>
+            <a:ext cx="548640" cy="274320"/>
+          </a:xfrm>
+          <a:prstGeom prst="roundRect">
+            <a:avLst/>
+          </a:prstGeom>
+          <a:solidFill>
+            <a:srgbClr val="10243E"/>
+          </a:solidFill>
+          <a:ln>
+            <a:noFill/>
+          </a:ln>
+          <a:effectLst/>
+        </p:spPr>
+        <p:style>
+          <a:lnRef idx="1">
+            <a:schemeClr val="accent1"/>
+          </a:lnRef>
+          <a:fillRef idx="3">
+            <a:schemeClr val="accent1"/>
+          </a:fillRef>
+          <a:effectRef idx="2">
+            <a:schemeClr val="accent1"/>
+          </a:effectRef>
+          <a:fontRef idx="minor">
+            <a:schemeClr val="lt1"/>
+          </a:fontRef>
+        </p:style>
+        <p:txBody>
+          <a:bodyPr rtlCol="0" anchor="ctr" wrap="none" lIns="0" rIns="0" tIns="0" bIns="0"/>
+          <a:lstStyle/>
+          <a:p>
+            <a:pPr algn="ctr"/>
+            <a:r>
+              <a:rPr sz="1300" b="1">
+                <a:solidFill>
+                  <a:srgbClr val="FFFFFF"/>
+                </a:solidFill>
+                <a:latin typeface="Aptos"/>
+              </a:rPr>
+              <a:t>E2</a:t>
+            </a:r>
+          </a:p>
+        </p:txBody>
+      </p:sp>
     </p:spTree>
   </p:cSld>
   <p:clrMapOvr>
@@ -17183,6 +17395,112 @@
           </a:prstGeom>
         </p:spPr>
       </p:pic>
+      <p:sp>
+        <p:nvSpPr>
+          <p:cNvPr id="11" name="Rounded Rectangle 10"/>
+          <p:cNvSpPr/>
+          <p:nvPr/>
+        </p:nvSpPr>
+        <p:spPr>
+          <a:xfrm>
+            <a:off x="411480" y="1243584"/>
+            <a:ext cx="548640" cy="274320"/>
+          </a:xfrm>
+          <a:prstGeom prst="roundRect">
+            <a:avLst/>
+          </a:prstGeom>
+          <a:solidFill>
+            <a:srgbClr val="10243E"/>
+          </a:solidFill>
+          <a:ln>
+            <a:noFill/>
+          </a:ln>
+          <a:effectLst/>
+        </p:spPr>
+        <p:style>
+          <a:lnRef idx="1">
+            <a:schemeClr val="accent1"/>
+          </a:lnRef>
+          <a:fillRef idx="3">
+            <a:schemeClr val="accent1"/>
+          </a:fillRef>
+          <a:effectRef idx="2">
+            <a:schemeClr val="accent1"/>
+          </a:effectRef>
+          <a:fontRef idx="minor">
+            <a:schemeClr val="lt1"/>
+          </a:fontRef>
+        </p:style>
+        <p:txBody>
+          <a:bodyPr rtlCol="0" anchor="ctr" wrap="none" lIns="0" rIns="0" tIns="0" bIns="0"/>
+          <a:lstStyle/>
+          <a:p>
+            <a:pPr algn="ctr"/>
+            <a:r>
+              <a:rPr sz="1300" b="1">
+                <a:solidFill>
+                  <a:srgbClr val="FFFFFF"/>
+                </a:solidFill>
+                <a:latin typeface="Aptos"/>
+              </a:rPr>
+              <a:t>E3</a:t>
+            </a:r>
+          </a:p>
+        </p:txBody>
+      </p:sp>
+      <p:sp>
+        <p:nvSpPr>
+          <p:cNvPr id="12" name="Rounded Rectangle 11"/>
+          <p:cNvSpPr/>
+          <p:nvPr/>
+        </p:nvSpPr>
+        <p:spPr>
+          <a:xfrm>
+            <a:off x="6199632" y="1243584"/>
+            <a:ext cx="548640" cy="274320"/>
+          </a:xfrm>
+          <a:prstGeom prst="roundRect">
+            <a:avLst/>
+          </a:prstGeom>
+          <a:solidFill>
+            <a:srgbClr val="10243E"/>
+          </a:solidFill>
+          <a:ln>
+            <a:noFill/>
+          </a:ln>
+          <a:effectLst/>
+        </p:spPr>
+        <p:style>
+          <a:lnRef idx="1">
+            <a:schemeClr val="accent1"/>
+          </a:lnRef>
+          <a:fillRef idx="3">
+            <a:schemeClr val="accent1"/>
+          </a:fillRef>
+          <a:effectRef idx="2">
+            <a:schemeClr val="accent1"/>
+          </a:effectRef>
+          <a:fontRef idx="minor">
+            <a:schemeClr val="lt1"/>
+          </a:fontRef>
+        </p:style>
+        <p:txBody>
+          <a:bodyPr rtlCol="0" anchor="ctr" wrap="none" lIns="0" rIns="0" tIns="0" bIns="0"/>
+          <a:lstStyle/>
+          <a:p>
+            <a:pPr algn="ctr"/>
+            <a:r>
+              <a:rPr sz="1300" b="1">
+                <a:solidFill>
+                  <a:srgbClr val="FFFFFF"/>
+                </a:solidFill>
+                <a:latin typeface="Aptos"/>
+              </a:rPr>
+              <a:t>E4</a:t>
+            </a:r>
+          </a:p>
+        </p:txBody>
+      </p:sp>
     </p:spTree>
   </p:cSld>
   <p:clrMapOvr>
@@ -17451,6 +17769,112 @@
           </a:prstGeom>
         </p:spPr>
       </p:pic>
+      <p:sp>
+        <p:nvSpPr>
+          <p:cNvPr id="11" name="Rounded Rectangle 10"/>
+          <p:cNvSpPr/>
+          <p:nvPr/>
+        </p:nvSpPr>
+        <p:spPr>
+          <a:xfrm>
+            <a:off x="411480" y="1243584"/>
+            <a:ext cx="548640" cy="274320"/>
+          </a:xfrm>
+          <a:prstGeom prst="roundRect">
+            <a:avLst/>
+          </a:prstGeom>
+          <a:solidFill>
+            <a:srgbClr val="10243E"/>
+          </a:solidFill>
+          <a:ln>
+            <a:noFill/>
+          </a:ln>
+          <a:effectLst/>
+        </p:spPr>
+        <p:style>
+          <a:lnRef idx="1">
+            <a:schemeClr val="accent1"/>
+          </a:lnRef>
+          <a:fillRef idx="3">
+            <a:schemeClr val="accent1"/>
+          </a:fillRef>
+          <a:effectRef idx="2">
+            <a:schemeClr val="accent1"/>
+          </a:effectRef>
+          <a:fontRef idx="minor">
+            <a:schemeClr val="lt1"/>
+          </a:fontRef>
+        </p:style>
+        <p:txBody>
+          <a:bodyPr rtlCol="0" anchor="ctr" wrap="none" lIns="0" rIns="0" tIns="0" bIns="0"/>
+          <a:lstStyle/>
+          <a:p>
+            <a:pPr algn="ctr"/>
+            <a:r>
+              <a:rPr sz="1300" b="1">
+                <a:solidFill>
+                  <a:srgbClr val="FFFFFF"/>
+                </a:solidFill>
+                <a:latin typeface="Aptos"/>
+              </a:rPr>
+              <a:t>E5</a:t>
+            </a:r>
+          </a:p>
+        </p:txBody>
+      </p:sp>
+      <p:sp>
+        <p:nvSpPr>
+          <p:cNvPr id="12" name="Rounded Rectangle 11"/>
+          <p:cNvSpPr/>
+          <p:nvPr/>
+        </p:nvSpPr>
+        <p:spPr>
+          <a:xfrm>
+            <a:off x="6199632" y="1243584"/>
+            <a:ext cx="548640" cy="274320"/>
+          </a:xfrm>
+          <a:prstGeom prst="roundRect">
+            <a:avLst/>
+          </a:prstGeom>
+          <a:solidFill>
+            <a:srgbClr val="10243E"/>
+          </a:solidFill>
+          <a:ln>
+            <a:noFill/>
+          </a:ln>
+          <a:effectLst/>
+        </p:spPr>
+        <p:style>
+          <a:lnRef idx="1">
+            <a:schemeClr val="accent1"/>
+          </a:lnRef>
+          <a:fillRef idx="3">
+            <a:schemeClr val="accent1"/>
+          </a:fillRef>
+          <a:effectRef idx="2">
+            <a:schemeClr val="accent1"/>
+          </a:effectRef>
+          <a:fontRef idx="minor">
+            <a:schemeClr val="lt1"/>
+          </a:fontRef>
+        </p:style>
+        <p:txBody>
+          <a:bodyPr rtlCol="0" anchor="ctr" wrap="none" lIns="0" rIns="0" tIns="0" bIns="0"/>
+          <a:lstStyle/>
+          <a:p>
+            <a:pPr algn="ctr"/>
+            <a:r>
+              <a:rPr sz="1300" b="1">
+                <a:solidFill>
+                  <a:srgbClr val="FFFFFF"/>
+                </a:solidFill>
+                <a:latin typeface="Aptos"/>
+              </a:rPr>
+              <a:t>E5</a:t>
+            </a:r>
+          </a:p>
+        </p:txBody>
+      </p:sp>
     </p:spTree>
   </p:cSld>
   <p:clrMapOvr>
@@ -17695,6 +18119,59 @@
           </a:prstGeom>
         </p:spPr>
       </p:pic>
+      <p:sp>
+        <p:nvSpPr>
+          <p:cNvPr id="10" name="Rounded Rectangle 9"/>
+          <p:cNvSpPr/>
+          <p:nvPr/>
+        </p:nvSpPr>
+        <p:spPr>
+          <a:xfrm>
+            <a:off x="822960" y="1024128"/>
+            <a:ext cx="548640" cy="274320"/>
+          </a:xfrm>
+          <a:prstGeom prst="roundRect">
+            <a:avLst/>
+          </a:prstGeom>
+          <a:solidFill>
+            <a:srgbClr val="10243E"/>
+          </a:solidFill>
+          <a:ln>
+            <a:noFill/>
+          </a:ln>
+          <a:effectLst/>
+        </p:spPr>
+        <p:style>
+          <a:lnRef idx="1">
+            <a:schemeClr val="accent1"/>
+          </a:lnRef>
+          <a:fillRef idx="3">
+            <a:schemeClr val="accent1"/>
+          </a:fillRef>
+          <a:effectRef idx="2">
+            <a:schemeClr val="accent1"/>
+          </a:effectRef>
+          <a:fontRef idx="minor">
+            <a:schemeClr val="lt1"/>
+          </a:fontRef>
+        </p:style>
+        <p:txBody>
+          <a:bodyPr rtlCol="0" anchor="ctr" wrap="none" lIns="0" rIns="0" tIns="0" bIns="0"/>
+          <a:lstStyle/>
+          <a:p>
+            <a:pPr algn="ctr"/>
+            <a:r>
+              <a:rPr sz="1300" b="1">
+                <a:solidFill>
+                  <a:srgbClr val="FFFFFF"/>
+                </a:solidFill>
+                <a:latin typeface="Aptos"/>
+              </a:rPr>
+              <a:t>E5</a:t>
+            </a:r>
+          </a:p>
+        </p:txBody>
+      </p:sp>
     </p:spTree>
   </p:cSld>
   <p:clrMapOvr>
@@ -20243,6 +20720,59 @@
           </a:prstGeom>
         </p:spPr>
       </p:pic>
+      <p:sp>
+        <p:nvSpPr>
+          <p:cNvPr id="10" name="Rounded Rectangle 9"/>
+          <p:cNvSpPr/>
+          <p:nvPr/>
+        </p:nvSpPr>
+        <p:spPr>
+          <a:xfrm>
+            <a:off x="822960" y="1024128"/>
+            <a:ext cx="548640" cy="274320"/>
+          </a:xfrm>
+          <a:prstGeom prst="roundRect">
+            <a:avLst/>
+          </a:prstGeom>
+          <a:solidFill>
+            <a:srgbClr val="10243E"/>
+          </a:solidFill>
+          <a:ln>
+            <a:noFill/>
+          </a:ln>
+          <a:effectLst/>
+        </p:spPr>
+        <p:style>
+          <a:lnRef idx="1">
+            <a:schemeClr val="accent1"/>
+          </a:lnRef>
+          <a:fillRef idx="3">
+            <a:schemeClr val="accent1"/>
+          </a:fillRef>
+          <a:effectRef idx="2">
+            <a:schemeClr val="accent1"/>
+          </a:effectRef>
+          <a:fontRef idx="minor">
+            <a:schemeClr val="lt1"/>
+          </a:fontRef>
+        </p:style>
+        <p:txBody>
+          <a:bodyPr rtlCol="0" anchor="ctr" wrap="none" lIns="0" rIns="0" tIns="0" bIns="0"/>
+          <a:lstStyle/>
+          <a:p>
+            <a:pPr algn="ctr"/>
+            <a:r>
+              <a:rPr sz="1300" b="1">
+                <a:solidFill>
+                  <a:srgbClr val="FFFFFF"/>
+                </a:solidFill>
+                <a:latin typeface="Aptos"/>
+              </a:rPr>
+              <a:t>E6</a:t>
+            </a:r>
+          </a:p>
+        </p:txBody>
+      </p:sp>
     </p:spTree>
   </p:cSld>
   <p:clrMapOvr>
@@ -20487,6 +21017,59 @@
           </a:prstGeom>
         </p:spPr>
       </p:pic>
+      <p:sp>
+        <p:nvSpPr>
+          <p:cNvPr id="10" name="Rounded Rectangle 9"/>
+          <p:cNvSpPr/>
+          <p:nvPr/>
+        </p:nvSpPr>
+        <p:spPr>
+          <a:xfrm>
+            <a:off x="822960" y="1024128"/>
+            <a:ext cx="548640" cy="274320"/>
+          </a:xfrm>
+          <a:prstGeom prst="roundRect">
+            <a:avLst/>
+          </a:prstGeom>
+          <a:solidFill>
+            <a:srgbClr val="10243E"/>
+          </a:solidFill>
+          <a:ln>
+            <a:noFill/>
+          </a:ln>
+          <a:effectLst/>
+        </p:spPr>
+        <p:style>
+          <a:lnRef idx="1">
+            <a:schemeClr val="accent1"/>
+          </a:lnRef>
+          <a:fillRef idx="3">
+            <a:schemeClr val="accent1"/>
+          </a:fillRef>
+          <a:effectRef idx="2">
+            <a:schemeClr val="accent1"/>
+          </a:effectRef>
+          <a:fontRef idx="minor">
+            <a:schemeClr val="lt1"/>
+          </a:fontRef>
+        </p:style>
+        <p:txBody>
+          <a:bodyPr rtlCol="0" anchor="ctr" wrap="none" lIns="0" rIns="0" tIns="0" bIns="0"/>
+          <a:lstStyle/>
+          <a:p>
+            <a:pPr algn="ctr"/>
+            <a:r>
+              <a:rPr sz="1300" b="1">
+                <a:solidFill>
+                  <a:srgbClr val="FFFFFF"/>
+                </a:solidFill>
+                <a:latin typeface="Aptos"/>
+              </a:rPr>
+              <a:t>E6</a:t>
+            </a:r>
+          </a:p>
+        </p:txBody>
+      </p:sp>
     </p:spTree>
   </p:cSld>
   <p:clrMapOvr>
@@ -20731,6 +21314,59 @@
           </a:prstGeom>
         </p:spPr>
       </p:pic>
+      <p:sp>
+        <p:nvSpPr>
+          <p:cNvPr id="10" name="Rounded Rectangle 9"/>
+          <p:cNvSpPr/>
+          <p:nvPr/>
+        </p:nvSpPr>
+        <p:spPr>
+          <a:xfrm>
+            <a:off x="822960" y="1024128"/>
+            <a:ext cx="548640" cy="274320"/>
+          </a:xfrm>
+          <a:prstGeom prst="roundRect">
+            <a:avLst/>
+          </a:prstGeom>
+          <a:solidFill>
+            <a:srgbClr val="10243E"/>
+          </a:solidFill>
+          <a:ln>
+            <a:noFill/>
+          </a:ln>
+          <a:effectLst/>
+        </p:spPr>
+        <p:style>
+          <a:lnRef idx="1">
+            <a:schemeClr val="accent1"/>
+          </a:lnRef>
+          <a:fillRef idx="3">
+            <a:schemeClr val="accent1"/>
+          </a:fillRef>
+          <a:effectRef idx="2">
+            <a:schemeClr val="accent1"/>
+          </a:effectRef>
+          <a:fontRef idx="minor">
+            <a:schemeClr val="lt1"/>
+          </a:fontRef>
+        </p:style>
+        <p:txBody>
+          <a:bodyPr rtlCol="0" anchor="ctr" wrap="none" lIns="0" rIns="0" tIns="0" bIns="0"/>
+          <a:lstStyle/>
+          <a:p>
+            <a:pPr algn="ctr"/>
+            <a:r>
+              <a:rPr sz="1300" b="1">
+                <a:solidFill>
+                  <a:srgbClr val="FFFFFF"/>
+                </a:solidFill>
+                <a:latin typeface="Aptos"/>
+              </a:rPr>
+              <a:t>E6</a:t>
+            </a:r>
+          </a:p>
+        </p:txBody>
+      </p:sp>
     </p:spTree>
   </p:cSld>
   <p:clrMapOvr>
@@ -20975,6 +21611,59 @@
           </a:prstGeom>
         </p:spPr>
       </p:pic>
+      <p:sp>
+        <p:nvSpPr>
+          <p:cNvPr id="10" name="Rounded Rectangle 9"/>
+          <p:cNvSpPr/>
+          <p:nvPr/>
+        </p:nvSpPr>
+        <p:spPr>
+          <a:xfrm>
+            <a:off x="822960" y="1024128"/>
+            <a:ext cx="548640" cy="274320"/>
+          </a:xfrm>
+          <a:prstGeom prst="roundRect">
+            <a:avLst/>
+          </a:prstGeom>
+          <a:solidFill>
+            <a:srgbClr val="10243E"/>
+          </a:solidFill>
+          <a:ln>
+            <a:noFill/>
+          </a:ln>
+          <a:effectLst/>
+        </p:spPr>
+        <p:style>
+          <a:lnRef idx="1">
+            <a:schemeClr val="accent1"/>
+          </a:lnRef>
+          <a:fillRef idx="3">
+            <a:schemeClr val="accent1"/>
+          </a:fillRef>
+          <a:effectRef idx="2">
+            <a:schemeClr val="accent1"/>
+          </a:effectRef>
+          <a:fontRef idx="minor">
+            <a:schemeClr val="lt1"/>
+          </a:fontRef>
+        </p:style>
+        <p:txBody>
+          <a:bodyPr rtlCol="0" anchor="ctr" wrap="none" lIns="0" rIns="0" tIns="0" bIns="0"/>
+          <a:lstStyle/>
+          <a:p>
+            <a:pPr algn="ctr"/>
+            <a:r>
+              <a:rPr sz="1300" b="1">
+                <a:solidFill>
+                  <a:srgbClr val="FFFFFF"/>
+                </a:solidFill>
+                <a:latin typeface="Aptos"/>
+              </a:rPr>
+              <a:t>E6</a:t>
+            </a:r>
+          </a:p>
+        </p:txBody>
+      </p:sp>
     </p:spTree>
   </p:cSld>
   <p:clrMapOvr>
@@ -21219,6 +21908,59 @@
           </a:prstGeom>
         </p:spPr>
       </p:pic>
+      <p:sp>
+        <p:nvSpPr>
+          <p:cNvPr id="10" name="Rounded Rectangle 9"/>
+          <p:cNvSpPr/>
+          <p:nvPr/>
+        </p:nvSpPr>
+        <p:spPr>
+          <a:xfrm>
+            <a:off x="822960" y="1024128"/>
+            <a:ext cx="548640" cy="274320"/>
+          </a:xfrm>
+          <a:prstGeom prst="roundRect">
+            <a:avLst/>
+          </a:prstGeom>
+          <a:solidFill>
+            <a:srgbClr val="10243E"/>
+          </a:solidFill>
+          <a:ln>
+            <a:noFill/>
+          </a:ln>
+          <a:effectLst/>
+        </p:spPr>
+        <p:style>
+          <a:lnRef idx="1">
+            <a:schemeClr val="accent1"/>
+          </a:lnRef>
+          <a:fillRef idx="3">
+            <a:schemeClr val="accent1"/>
+          </a:fillRef>
+          <a:effectRef idx="2">
+            <a:schemeClr val="accent1"/>
+          </a:effectRef>
+          <a:fontRef idx="minor">
+            <a:schemeClr val="lt1"/>
+          </a:fontRef>
+        </p:style>
+        <p:txBody>
+          <a:bodyPr rtlCol="0" anchor="ctr" wrap="none" lIns="0" rIns="0" tIns="0" bIns="0"/>
+          <a:lstStyle/>
+          <a:p>
+            <a:pPr algn="ctr"/>
+            <a:r>
+              <a:rPr sz="1300" b="1">
+                <a:solidFill>
+                  <a:srgbClr val="FFFFFF"/>
+                </a:solidFill>
+                <a:latin typeface="Aptos"/>
+              </a:rPr>
+              <a:t>E6</a:t>
+            </a:r>
+          </a:p>
+        </p:txBody>
+      </p:sp>
     </p:spTree>
   </p:cSld>
   <p:clrMapOvr>

</xml_diff>